<commit_message>
Deck are generated in a good way
</commit_message>
<xml_diff>
--- a/learning-test-course-docker/material/slides/out/session-01.pptx
+++ b/learning-test-course-docker/material/slides/out/session-01.pptx
@@ -689,9 +689,9 @@
                 </a:solidFill>
                 <a:latin typeface="Calibri"/>
               </a:rPr>
-              <a:t>[links] Rimando in avanti: la domanda viene ripresa in una sessione successiva dedicata alla
-persistenza dei dati (vedi instructional_decisions per la scelta di non nominare qui il
-meccanismo che la risolve).
+              <a:t>[links] Rimando in avanti: la domanda viene ripresa nella sessione 4, dedicata alla persistenza
+dei dati (vedi instructional_decisions per la scelta di non nominare qui il meccanismo
+che la risolve).
 </a:t>
             </a:r>
           </a:p>
@@ -787,9 +787,10 @@
                 </a:solidFill>
                 <a:latin typeface="Calibri"/>
               </a:rPr>
-              <a:t>[talk] Prima occorrenza degli acronimi in questo documento: stdin (standard input, "canale di
-ingresso standard"), stdout (standard output, "canale di uscita standard"), stderr
-(standard error, "canale di errore standard"). Da qui in poi puoi usarli liberamente.
+              <a:t>[talk] Prima occorrenza degli acronimi in questo documento, già glossati sullo schermo: stdin
+(standard input, canale di ingresso standard), stdout (standard output, canale di uscita
+standard), stderr (standard error, canale di errore standard). Da qui in poi puoi usarli
+liberamente, sia tu che gli studenti.
 </a:t>
             </a:r>
           </a:p>
@@ -917,10 +918,9 @@
                 </a:solidFill>
                 <a:latin typeface="Calibri"/>
               </a:rPr>
-              <a:t>[talk] Prima occorrenza dell'acronimo tty in questo documento: tty sta per "teletypewriter",
-un termine storico che qui si può tradurre come "terminale". Collega il termine
-all'esperienza già fatta dagli studenti (la finestra di terminale usata per la shell,
-BSL-SHELL).
+              <a:t>[talk] Collega il termine tty all'esperienza già fatta dagli studenti: la finestra di terminale
+usata per la shell (BSL-SHELL) è, tecnicamente, l'erede moderno di quello che un tempo
+era un dispositivo fisico (il teletypewriter da cui viene il nome).
 </a:t>
             </a:r>
           </a:p>
@@ -1800,8 +1800,11 @@
                 <a:latin typeface="Calibri"/>
               </a:rPr>
               <a:t>[talk] Questa slide introduce la demo dal vivo (sequence 6): il docente esegue davvero questi tre
-comandi al terminale, commentando cosa restituisce ciascuno. Non spiegare qui la sintassi
-completa dei comandi (arriva come PRQ-CLI-BASICS, sessione 2): l'obiettivo è rendere
+comandi al terminale, commentando cosa restituisce ciascuno. `nginx` è un esempio scelto
+dall'autore di questo deck per avere un'immagine piccola e nota [invented framing]:
+qualunque immagine leggera va bene, nessuno store ne prescrive una specifica. Non
+spiegare qui la sintassi completa dei comandi (arriva come PRQ-CLI-BASICS, sessione 2,
+CLI = command-line interface, interfaccia a riga di comando): l'obiettivo è rendere
 concreto il concetto di container appena visto, non insegnare la CLI in dettaglio.
 </a:t>
             </a:r>
@@ -5332,6 +5335,41 @@
           </a:p>
         </p:txBody>
       </p:sp>
+      <p:sp>
+        <p:nvSpPr>
+          <p:cNvPr id="5" name="TextBox 4"/>
+          <p:cNvSpPr txBox="1"/>
+          <p:nvPr/>
+        </p:nvSpPr>
+        <p:spPr>
+          <a:xfrm>
+            <a:off x="10180015" y="137160"/>
+            <a:ext cx="1828800" cy="365760"/>
+          </a:xfrm>
+          <a:prstGeom prst="rect">
+            <a:avLst/>
+          </a:prstGeom>
+          <a:noFill/>
+        </p:spPr>
+        <p:txBody>
+          <a:bodyPr wrap="square">
+            <a:spAutoFit/>
+          </a:bodyPr>
+          <a:lstStyle/>
+          <a:p>
+            <a:pPr algn="r"/>
+            <a:r>
+              <a:rPr sz="1400" b="1" i="0">
+                <a:solidFill>
+                  <a:srgbClr val="C01C1C"/>
+                </a:solidFill>
+                <a:latin typeface="Calibri"/>
+              </a:rPr>
+              <a:t>[DRAFT]</a:t>
+            </a:r>
+          </a:p>
+        </p:txBody>
+      </p:sp>
     </p:spTree>
   </p:cSld>
   <p:clrMapOvr>
@@ -5424,7 +5462,7 @@
                 </a:solidFill>
                 <a:latin typeface="Consolas"/>
               </a:rPr>
-              <a:t>docker run ...</a:t>
+              <a:t>docker run -d --name web nginx</a:t>
             </a:r>
           </a:p>
           <a:p>
@@ -5446,7 +5484,42 @@
                 </a:solidFill>
                 <a:latin typeface="Consolas"/>
               </a:rPr>
-              <a:t>docker stop ...</a:t>
+              <a:t>docker stop web</a:t>
+            </a:r>
+          </a:p>
+        </p:txBody>
+      </p:sp>
+      <p:sp>
+        <p:nvSpPr>
+          <p:cNvPr id="4" name="TextBox 3"/>
+          <p:cNvSpPr txBox="1"/>
+          <p:nvPr/>
+        </p:nvSpPr>
+        <p:spPr>
+          <a:xfrm>
+            <a:off x="10180015" y="137160"/>
+            <a:ext cx="1828800" cy="365760"/>
+          </a:xfrm>
+          <a:prstGeom prst="rect">
+            <a:avLst/>
+          </a:prstGeom>
+          <a:noFill/>
+        </p:spPr>
+        <p:txBody>
+          <a:bodyPr wrap="square">
+            <a:spAutoFit/>
+          </a:bodyPr>
+          <a:lstStyle/>
+          <a:p>
+            <a:pPr algn="r"/>
+            <a:r>
+              <a:rPr sz="1400" b="1" i="0">
+                <a:solidFill>
+                  <a:srgbClr val="C01C1C"/>
+                </a:solidFill>
+                <a:latin typeface="Calibri"/>
+              </a:rPr>
+              <a:t>[DRAFT]</a:t>
             </a:r>
           </a:p>
         </p:txBody>
@@ -5504,6 +5577,41 @@
           </a:p>
         </p:txBody>
       </p:sp>
+      <p:sp>
+        <p:nvSpPr>
+          <p:cNvPr id="3" name="TextBox 2"/>
+          <p:cNvSpPr txBox="1"/>
+          <p:nvPr/>
+        </p:nvSpPr>
+        <p:spPr>
+          <a:xfrm>
+            <a:off x="10180015" y="137160"/>
+            <a:ext cx="1828800" cy="365760"/>
+          </a:xfrm>
+          <a:prstGeom prst="rect">
+            <a:avLst/>
+          </a:prstGeom>
+          <a:noFill/>
+        </p:spPr>
+        <p:txBody>
+          <a:bodyPr wrap="square">
+            <a:spAutoFit/>
+          </a:bodyPr>
+          <a:lstStyle/>
+          <a:p>
+            <a:pPr algn="r"/>
+            <a:r>
+              <a:rPr sz="1400" b="1" i="0">
+                <a:solidFill>
+                  <a:srgbClr val="C01C1C"/>
+                </a:solidFill>
+                <a:latin typeface="Calibri"/>
+              </a:rPr>
+              <a:t>[DRAFT]</a:t>
+            </a:r>
+          </a:p>
+        </p:txBody>
+      </p:sp>
     </p:spTree>
   </p:cSld>
   <p:clrMapOvr>
@@ -5577,6 +5685,54 @@
             <a:spAutoFit/>
           </a:bodyPr>
           <a:lstStyle/>
+          <a:p/>
+        </p:txBody>
+      </p:sp>
+      <p:pic>
+        <p:nvPicPr>
+          <p:cNvPr id="4" name="Picture 3" descr="S1-07.png"/>
+          <p:cNvPicPr>
+            <a:picLocks noChangeAspect="1"/>
+          </p:cNvPicPr>
+          <p:nvPr/>
+        </p:nvPicPr>
+        <p:blipFill>
+          <a:blip r:embed="rId2"/>
+          <a:stretch>
+            <a:fillRect/>
+          </a:stretch>
+        </p:blipFill>
+        <p:spPr>
+          <a:xfrm>
+            <a:off x="548640" y="2942740"/>
+            <a:ext cx="11094415" cy="881079"/>
+          </a:xfrm>
+          <a:prstGeom prst="rect">
+            <a:avLst/>
+          </a:prstGeom>
+        </p:spPr>
+      </p:pic>
+      <p:sp>
+        <p:nvSpPr>
+          <p:cNvPr id="5" name="TextBox 4"/>
+          <p:cNvSpPr txBox="1"/>
+          <p:nvPr/>
+        </p:nvSpPr>
+        <p:spPr>
+          <a:xfrm>
+            <a:off x="548640" y="5394960"/>
+            <a:ext cx="11094415" cy="365760"/>
+          </a:xfrm>
+          <a:prstGeom prst="rect">
+            <a:avLst/>
+          </a:prstGeom>
+          <a:noFill/>
+        </p:spPr>
+        <p:txBody>
+          <a:bodyPr wrap="square">
+            <a:spAutoFit/>
+          </a:bodyPr>
+          <a:lstStyle/>
           <a:p>
             <a:r>
               <a:rPr sz="1400" b="0" i="1">
@@ -5585,51 +5741,42 @@
                 </a:solidFill>
                 <a:latin typeface="Calibri"/>
               </a:rPr>
-              <a:t>[DIAGRAM SOURCE — draw by hand, not rendered by this script]  Dal sorgente a un'altra macchina</a:t>
-            </a:r>
-          </a:p>
-          <a:p>
-            <a:r>
-              <a:rPr sz="1400" b="0" i="0">
-                <a:solidFill>
-                  <a:srgbClr val="1A1A1A"/>
-                </a:solidFill>
-                <a:latin typeface="Consolas"/>
-              </a:rPr>
-              <a:t>flowchart LR</a:t>
-            </a:r>
-          </a:p>
-          <a:p>
-            <a:r>
-              <a:rPr sz="1400" b="0" i="0">
-                <a:solidFill>
-                  <a:srgbClr val="1A1A1A"/>
-                </a:solidFill>
-                <a:latin typeface="Consolas"/>
-              </a:rPr>
-              <a:t>  S[Sorgente] --&gt; Im[Immagine v1]</a:t>
-            </a:r>
-          </a:p>
-          <a:p>
-            <a:r>
-              <a:rPr sz="1400" b="0" i="0">
-                <a:solidFill>
-                  <a:srgbClr val="1A1A1A"/>
-                </a:solidFill>
-                <a:latin typeface="Consolas"/>
-              </a:rPr>
-              <a:t>  Im --&gt; Ar[Archivio condiviso]</a:t>
-            </a:r>
-          </a:p>
-          <a:p>
-            <a:r>
-              <a:rPr sz="1400" b="0" i="0">
-                <a:solidFill>
-                  <a:srgbClr val="1A1A1A"/>
-                </a:solidFill>
-                <a:latin typeface="Consolas"/>
-              </a:rPr>
-              <a:t>  Ar --&gt; M[Altra macchina]</a:t>
+              <a:t>Dal sorgente a un'altra macchina</a:t>
+            </a:r>
+          </a:p>
+        </p:txBody>
+      </p:sp>
+      <p:sp>
+        <p:nvSpPr>
+          <p:cNvPr id="6" name="TextBox 5"/>
+          <p:cNvSpPr txBox="1"/>
+          <p:nvPr/>
+        </p:nvSpPr>
+        <p:spPr>
+          <a:xfrm>
+            <a:off x="10180015" y="137160"/>
+            <a:ext cx="1828800" cy="365760"/>
+          </a:xfrm>
+          <a:prstGeom prst="rect">
+            <a:avLst/>
+          </a:prstGeom>
+          <a:noFill/>
+        </p:spPr>
+        <p:txBody>
+          <a:bodyPr wrap="square">
+            <a:spAutoFit/>
+          </a:bodyPr>
+          <a:lstStyle/>
+          <a:p>
+            <a:pPr algn="r"/>
+            <a:r>
+              <a:rPr sz="1400" b="1" i="0">
+                <a:solidFill>
+                  <a:srgbClr val="C01C1C"/>
+                </a:solidFill>
+                <a:latin typeface="Calibri"/>
+              </a:rPr>
+              <a:t>[DRAFT]</a:t>
             </a:r>
           </a:p>
         </p:txBody>
@@ -5707,6 +5854,54 @@
             <a:spAutoFit/>
           </a:bodyPr>
           <a:lstStyle/>
+          <a:p/>
+        </p:txBody>
+      </p:sp>
+      <p:pic>
+        <p:nvPicPr>
+          <p:cNvPr id="4" name="Picture 3" descr="S1-08.png"/>
+          <p:cNvPicPr>
+            <a:picLocks noChangeAspect="1"/>
+          </p:cNvPicPr>
+          <p:nvPr/>
+        </p:nvPicPr>
+        <p:blipFill>
+          <a:blip r:embed="rId2"/>
+          <a:stretch>
+            <a:fillRect/>
+          </a:stretch>
+        </p:blipFill>
+        <p:spPr>
+          <a:xfrm>
+            <a:off x="2933547" y="1706880"/>
+            <a:ext cx="6324600" cy="3352800"/>
+          </a:xfrm>
+          <a:prstGeom prst="rect">
+            <a:avLst/>
+          </a:prstGeom>
+        </p:spPr>
+      </p:pic>
+      <p:sp>
+        <p:nvSpPr>
+          <p:cNvPr id="5" name="TextBox 4"/>
+          <p:cNvSpPr txBox="1"/>
+          <p:nvPr/>
+        </p:nvSpPr>
+        <p:spPr>
+          <a:xfrm>
+            <a:off x="548640" y="5394960"/>
+            <a:ext cx="11094415" cy="365760"/>
+          </a:xfrm>
+          <a:prstGeom prst="rect">
+            <a:avLst/>
+          </a:prstGeom>
+          <a:noFill/>
+        </p:spPr>
+        <p:txBody>
+          <a:bodyPr wrap="square">
+            <a:spAutoFit/>
+          </a:bodyPr>
+          <a:lstStyle/>
           <a:p>
             <a:r>
               <a:rPr sz="1400" b="0" i="1">
@@ -5715,40 +5910,42 @@
                 </a:solidFill>
                 <a:latin typeface="Calibri"/>
               </a:rPr>
-              <a:t>[DIAGRAM SOURCE — draw by hand, not rendered by this script]  Da un'immagine a più container</a:t>
-            </a:r>
-          </a:p>
-          <a:p>
-            <a:r>
-              <a:rPr sz="1400" b="0" i="0">
-                <a:solidFill>
-                  <a:srgbClr val="1A1A1A"/>
-                </a:solidFill>
-                <a:latin typeface="Consolas"/>
-              </a:rPr>
-              <a:t>flowchart LR</a:t>
-            </a:r>
-          </a:p>
-          <a:p>
-            <a:r>
-              <a:rPr sz="1400" b="0" i="0">
-                <a:solidFill>
-                  <a:srgbClr val="1A1A1A"/>
-                </a:solidFill>
-                <a:latin typeface="Consolas"/>
-              </a:rPr>
-              <a:t>  Im[Immagine] --&gt; C1[Container 1]</a:t>
-            </a:r>
-          </a:p>
-          <a:p>
-            <a:r>
-              <a:rPr sz="1400" b="0" i="0">
-                <a:solidFill>
-                  <a:srgbClr val="1A1A1A"/>
-                </a:solidFill>
-                <a:latin typeface="Consolas"/>
-              </a:rPr>
-              <a:t>  Im --&gt; C2[Container 2]</a:t>
+              <a:t>Da un'immagine a più container</a:t>
+            </a:r>
+          </a:p>
+        </p:txBody>
+      </p:sp>
+      <p:sp>
+        <p:nvSpPr>
+          <p:cNvPr id="6" name="TextBox 5"/>
+          <p:cNvSpPr txBox="1"/>
+          <p:nvPr/>
+        </p:nvSpPr>
+        <p:spPr>
+          <a:xfrm>
+            <a:off x="10180015" y="137160"/>
+            <a:ext cx="1828800" cy="365760"/>
+          </a:xfrm>
+          <a:prstGeom prst="rect">
+            <a:avLst/>
+          </a:prstGeom>
+          <a:noFill/>
+        </p:spPr>
+        <p:txBody>
+          <a:bodyPr wrap="square">
+            <a:spAutoFit/>
+          </a:bodyPr>
+          <a:lstStyle/>
+          <a:p>
+            <a:pPr algn="r"/>
+            <a:r>
+              <a:rPr sz="1400" b="1" i="0">
+                <a:solidFill>
+                  <a:srgbClr val="C01C1C"/>
+                </a:solidFill>
+                <a:latin typeface="Calibri"/>
+              </a:rPr>
+              <a:t>[DRAFT]</a:t>
             </a:r>
           </a:p>
         </p:txBody>
@@ -5806,6 +6003,41 @@
           </a:p>
         </p:txBody>
       </p:sp>
+      <p:sp>
+        <p:nvSpPr>
+          <p:cNvPr id="3" name="TextBox 2"/>
+          <p:cNvSpPr txBox="1"/>
+          <p:nvPr/>
+        </p:nvSpPr>
+        <p:spPr>
+          <a:xfrm>
+            <a:off x="10180015" y="137160"/>
+            <a:ext cx="1828800" cy="365760"/>
+          </a:xfrm>
+          <a:prstGeom prst="rect">
+            <a:avLst/>
+          </a:prstGeom>
+          <a:noFill/>
+        </p:spPr>
+        <p:txBody>
+          <a:bodyPr wrap="square">
+            <a:spAutoFit/>
+          </a:bodyPr>
+          <a:lstStyle/>
+          <a:p>
+            <a:pPr algn="r"/>
+            <a:r>
+              <a:rPr sz="1400" b="1" i="0">
+                <a:solidFill>
+                  <a:srgbClr val="C01C1C"/>
+                </a:solidFill>
+                <a:latin typeface="Calibri"/>
+              </a:rPr>
+              <a:t>[DRAFT]</a:t>
+            </a:r>
+          </a:p>
+        </p:txBody>
+      </p:sp>
     </p:spTree>
   </p:cSld>
   <p:clrMapOvr>
@@ -5879,6 +6111,54 @@
             <a:spAutoFit/>
           </a:bodyPr>
           <a:lstStyle/>
+          <a:p/>
+        </p:txBody>
+      </p:sp>
+      <p:pic>
+        <p:nvPicPr>
+          <p:cNvPr id="4" name="Picture 3" descr="S1-09.png"/>
+          <p:cNvPicPr>
+            <a:picLocks noChangeAspect="1"/>
+          </p:cNvPicPr>
+          <p:nvPr/>
+        </p:nvPicPr>
+        <p:blipFill>
+          <a:blip r:embed="rId2"/>
+          <a:stretch>
+            <a:fillRect/>
+          </a:stretch>
+        </p:blipFill>
+        <p:spPr>
+          <a:xfrm>
+            <a:off x="4250100" y="1463040"/>
+            <a:ext cx="3691495" cy="3840480"/>
+          </a:xfrm>
+          <a:prstGeom prst="rect">
+            <a:avLst/>
+          </a:prstGeom>
+        </p:spPr>
+      </p:pic>
+      <p:sp>
+        <p:nvSpPr>
+          <p:cNvPr id="5" name="TextBox 4"/>
+          <p:cNvSpPr txBox="1"/>
+          <p:nvPr/>
+        </p:nvSpPr>
+        <p:spPr>
+          <a:xfrm>
+            <a:off x="548640" y="5394960"/>
+            <a:ext cx="11094415" cy="365760"/>
+          </a:xfrm>
+          <a:prstGeom prst="rect">
+            <a:avLst/>
+          </a:prstGeom>
+          <a:noFill/>
+        </p:spPr>
+        <p:txBody>
+          <a:bodyPr wrap="square">
+            <a:spAutoFit/>
+          </a:bodyPr>
+          <a:lstStyle/>
           <a:p>
             <a:r>
               <a:rPr sz="1400" b="0" i="1">
@@ -5887,84 +6167,42 @@
                 </a:solidFill>
                 <a:latin typeface="Calibri"/>
               </a:rPr>
-              <a:t>[DIAGRAM SOURCE — draw by hand, not rendered by this script]  Due filesystem separati</a:t>
-            </a:r>
-          </a:p>
-          <a:p>
-            <a:r>
-              <a:rPr sz="1400" b="0" i="0">
-                <a:solidFill>
-                  <a:srgbClr val="1A1A1A"/>
-                </a:solidFill>
-                <a:latin typeface="Consolas"/>
-              </a:rPr>
-              <a:t>flowchart LR</a:t>
-            </a:r>
-          </a:p>
-          <a:p>
-            <a:r>
-              <a:rPr sz="1400" b="0" i="0">
-                <a:solidFill>
-                  <a:srgbClr val="1A1A1A"/>
-                </a:solidFill>
-                <a:latin typeface="Consolas"/>
-              </a:rPr>
-              <a:t>  subgraph Host[Filesystem host]</a:t>
-            </a:r>
-          </a:p>
-          <a:p>
-            <a:r>
-              <a:rPr sz="1400" b="0" i="0">
-                <a:solidFill>
-                  <a:srgbClr val="1A1A1A"/>
-                </a:solidFill>
-                <a:latin typeface="Consolas"/>
-              </a:rPr>
-              <a:t>    F1[File dell'host]</a:t>
-            </a:r>
-          </a:p>
-          <a:p>
-            <a:r>
-              <a:rPr sz="1400" b="0" i="0">
-                <a:solidFill>
-                  <a:srgbClr val="1A1A1A"/>
-                </a:solidFill>
-                <a:latin typeface="Consolas"/>
-              </a:rPr>
-              <a:t>  end</a:t>
-            </a:r>
-          </a:p>
-          <a:p>
-            <a:r>
-              <a:rPr sz="1400" b="0" i="0">
-                <a:solidFill>
-                  <a:srgbClr val="1A1A1A"/>
-                </a:solidFill>
-                <a:latin typeface="Consolas"/>
-              </a:rPr>
-              <a:t>  subgraph Cont[Filesystem container]</a:t>
-            </a:r>
-          </a:p>
-          <a:p>
-            <a:r>
-              <a:rPr sz="1400" b="0" i="0">
-                <a:solidFill>
-                  <a:srgbClr val="1A1A1A"/>
-                </a:solidFill>
-                <a:latin typeface="Consolas"/>
-              </a:rPr>
-              <a:t>    F2[File del container]</a:t>
-            </a:r>
-          </a:p>
-          <a:p>
-            <a:r>
-              <a:rPr sz="1400" b="0" i="0">
-                <a:solidFill>
-                  <a:srgbClr val="1A1A1A"/>
-                </a:solidFill>
-                <a:latin typeface="Consolas"/>
-              </a:rPr>
-              <a:t>  end</a:t>
+              <a:t>Due filesystem separati</a:t>
+            </a:r>
+          </a:p>
+        </p:txBody>
+      </p:sp>
+      <p:sp>
+        <p:nvSpPr>
+          <p:cNvPr id="6" name="TextBox 5"/>
+          <p:cNvSpPr txBox="1"/>
+          <p:nvPr/>
+        </p:nvSpPr>
+        <p:spPr>
+          <a:xfrm>
+            <a:off x="10180015" y="137160"/>
+            <a:ext cx="1828800" cy="365760"/>
+          </a:xfrm>
+          <a:prstGeom prst="rect">
+            <a:avLst/>
+          </a:prstGeom>
+          <a:noFill/>
+        </p:spPr>
+        <p:txBody>
+          <a:bodyPr wrap="square">
+            <a:spAutoFit/>
+          </a:bodyPr>
+          <a:lstStyle/>
+          <a:p>
+            <a:pPr algn="r"/>
+            <a:r>
+              <a:rPr sz="1400" b="1" i="0">
+                <a:solidFill>
+                  <a:srgbClr val="C01C1C"/>
+                </a:solidFill>
+                <a:latin typeface="Calibri"/>
+              </a:rPr>
+              <a:t>[DRAFT]</a:t>
             </a:r>
           </a:p>
         </p:txBody>
@@ -6056,6 +6294,41 @@
           </a:p>
         </p:txBody>
       </p:sp>
+      <p:sp>
+        <p:nvSpPr>
+          <p:cNvPr id="4" name="TextBox 3"/>
+          <p:cNvSpPr txBox="1"/>
+          <p:nvPr/>
+        </p:nvSpPr>
+        <p:spPr>
+          <a:xfrm>
+            <a:off x="10180015" y="137160"/>
+            <a:ext cx="1828800" cy="365760"/>
+          </a:xfrm>
+          <a:prstGeom prst="rect">
+            <a:avLst/>
+          </a:prstGeom>
+          <a:noFill/>
+        </p:spPr>
+        <p:txBody>
+          <a:bodyPr wrap="square">
+            <a:spAutoFit/>
+          </a:bodyPr>
+          <a:lstStyle/>
+          <a:p>
+            <a:pPr algn="r"/>
+            <a:r>
+              <a:rPr sz="1400" b="1" i="0">
+                <a:solidFill>
+                  <a:srgbClr val="C01C1C"/>
+                </a:solidFill>
+                <a:latin typeface="Calibri"/>
+              </a:rPr>
+              <a:t>[DRAFT]</a:t>
+            </a:r>
+          </a:p>
+        </p:txBody>
+      </p:sp>
     </p:spTree>
   </p:cSld>
   <p:clrMapOvr>
@@ -6109,6 +6382,41 @@
           </a:p>
         </p:txBody>
       </p:sp>
+      <p:sp>
+        <p:nvSpPr>
+          <p:cNvPr id="3" name="TextBox 2"/>
+          <p:cNvSpPr txBox="1"/>
+          <p:nvPr/>
+        </p:nvSpPr>
+        <p:spPr>
+          <a:xfrm>
+            <a:off x="10180015" y="137160"/>
+            <a:ext cx="1828800" cy="365760"/>
+          </a:xfrm>
+          <a:prstGeom prst="rect">
+            <a:avLst/>
+          </a:prstGeom>
+          <a:noFill/>
+        </p:spPr>
+        <p:txBody>
+          <a:bodyPr wrap="square">
+            <a:spAutoFit/>
+          </a:bodyPr>
+          <a:lstStyle/>
+          <a:p>
+            <a:pPr algn="r"/>
+            <a:r>
+              <a:rPr sz="1400" b="1" i="0">
+                <a:solidFill>
+                  <a:srgbClr val="C01C1C"/>
+                </a:solidFill>
+                <a:latin typeface="Calibri"/>
+              </a:rPr>
+              <a:t>[DRAFT]</a:t>
+            </a:r>
+          </a:p>
+        </p:txBody>
+      </p:sp>
     </p:spTree>
   </p:cSld>
   <p:clrMapOvr>
@@ -6182,6 +6490,54 @@
             <a:spAutoFit/>
           </a:bodyPr>
           <a:lstStyle/>
+          <a:p/>
+        </p:txBody>
+      </p:sp>
+      <p:pic>
+        <p:nvPicPr>
+          <p:cNvPr id="4" name="Picture 3" descr="S1-11.png"/>
+          <p:cNvPicPr>
+            <a:picLocks noChangeAspect="1"/>
+          </p:cNvPicPr>
+          <p:nvPr/>
+        </p:nvPicPr>
+        <p:blipFill>
+          <a:blip r:embed="rId2"/>
+          <a:stretch>
+            <a:fillRect/>
+          </a:stretch>
+        </p:blipFill>
+        <p:spPr>
+          <a:xfrm>
+            <a:off x="548640" y="2704030"/>
+            <a:ext cx="11094415" cy="1358499"/>
+          </a:xfrm>
+          <a:prstGeom prst="rect">
+            <a:avLst/>
+          </a:prstGeom>
+        </p:spPr>
+      </p:pic>
+      <p:sp>
+        <p:nvSpPr>
+          <p:cNvPr id="5" name="TextBox 4"/>
+          <p:cNvSpPr txBox="1"/>
+          <p:nvPr/>
+        </p:nvSpPr>
+        <p:spPr>
+          <a:xfrm>
+            <a:off x="548640" y="5394960"/>
+            <a:ext cx="11094415" cy="365760"/>
+          </a:xfrm>
+          <a:prstGeom prst="rect">
+            <a:avLst/>
+          </a:prstGeom>
+          <a:noFill/>
+        </p:spPr>
+        <p:txBody>
+          <a:bodyPr wrap="square">
+            <a:spAutoFit/>
+          </a:bodyPr>
+          <a:lstStyle/>
           <a:p>
             <a:r>
               <a:rPr sz="1400" b="0" i="1">
@@ -6190,84 +6546,42 @@
                 </a:solidFill>
                 <a:latin typeface="Calibri"/>
               </a:rPr>
-              <a:t>[DIAGRAM SOURCE — draw by hand, not rendered by this script]  I tre canali standard di un processo</a:t>
-            </a:r>
-          </a:p>
-          <a:p>
-            <a:r>
-              <a:rPr sz="1400" b="0" i="0">
-                <a:solidFill>
-                  <a:srgbClr val="1A1A1A"/>
-                </a:solidFill>
-                <a:latin typeface="Consolas"/>
-              </a:rPr>
-              <a:t>flowchart LR</a:t>
-            </a:r>
-          </a:p>
-          <a:p>
-            <a:r>
-              <a:rPr sz="1400" b="0" i="0">
-                <a:solidFill>
-                  <a:srgbClr val="1A1A1A"/>
-                </a:solidFill>
-                <a:latin typeface="Consolas"/>
-              </a:rPr>
-              <a:t>  Tastiera --&gt; StdIn[stdin - standard input]</a:t>
-            </a:r>
-          </a:p>
-          <a:p>
-            <a:r>
-              <a:rPr sz="1400" b="0" i="0">
-                <a:solidFill>
-                  <a:srgbClr val="1A1A1A"/>
-                </a:solidFill>
-                <a:latin typeface="Consolas"/>
-              </a:rPr>
-              <a:t>  StdIn --&gt; Processo</a:t>
-            </a:r>
-          </a:p>
-          <a:p>
-            <a:r>
-              <a:rPr sz="1400" b="0" i="0">
-                <a:solidFill>
-                  <a:srgbClr val="1A1A1A"/>
-                </a:solidFill>
-                <a:latin typeface="Consolas"/>
-              </a:rPr>
-              <a:t>  Processo --&gt; StdOut[stdout - standard output]</a:t>
-            </a:r>
-          </a:p>
-          <a:p>
-            <a:r>
-              <a:rPr sz="1400" b="0" i="0">
-                <a:solidFill>
-                  <a:srgbClr val="1A1A1A"/>
-                </a:solidFill>
-                <a:latin typeface="Consolas"/>
-              </a:rPr>
-              <a:t>  Processo --&gt; StdErr[stderr - standard error]</a:t>
-            </a:r>
-          </a:p>
-          <a:p>
-            <a:r>
-              <a:rPr sz="1400" b="0" i="0">
-                <a:solidFill>
-                  <a:srgbClr val="1A1A1A"/>
-                </a:solidFill>
-                <a:latin typeface="Consolas"/>
-              </a:rPr>
-              <a:t>  StdOut --&gt; Terminale</a:t>
-            </a:r>
-          </a:p>
-          <a:p>
-            <a:r>
-              <a:rPr sz="1400" b="0" i="0">
-                <a:solidFill>
-                  <a:srgbClr val="1A1A1A"/>
-                </a:solidFill>
-                <a:latin typeface="Consolas"/>
-              </a:rPr>
-              <a:t>  StdErr --&gt; Terminale</a:t>
+              <a:t>I tre canali standard di un processo</a:t>
+            </a:r>
+          </a:p>
+        </p:txBody>
+      </p:sp>
+      <p:sp>
+        <p:nvSpPr>
+          <p:cNvPr id="6" name="TextBox 5"/>
+          <p:cNvSpPr txBox="1"/>
+          <p:nvPr/>
+        </p:nvSpPr>
+        <p:spPr>
+          <a:xfrm>
+            <a:off x="10180015" y="137160"/>
+            <a:ext cx="1828800" cy="365760"/>
+          </a:xfrm>
+          <a:prstGeom prst="rect">
+            <a:avLst/>
+          </a:prstGeom>
+          <a:noFill/>
+        </p:spPr>
+        <p:txBody>
+          <a:bodyPr wrap="square">
+            <a:spAutoFit/>
+          </a:bodyPr>
+          <a:lstStyle/>
+          <a:p>
+            <a:pPr algn="r"/>
+            <a:r>
+              <a:rPr sz="1400" b="1" i="0">
+                <a:solidFill>
+                  <a:srgbClr val="C01C1C"/>
+                </a:solidFill>
+                <a:latin typeface="Calibri"/>
+              </a:rPr>
+              <a:t>[DRAFT]</a:t>
             </a:r>
           </a:p>
         </p:txBody>
@@ -6319,7 +6633,7 @@
                 </a:solidFill>
                 <a:latin typeface="Calibri"/>
               </a:rPr>
-              <a:t>Il terminale (tty) permette di dare input a un processo e leggerne l'output in tempo reale.</a:t>
+              <a:t>Il terminale (tty, dall'inglese «teletypewriter») permette di dare input a un processo e leggerne l'output in tempo reale.</a:t>
             </a:r>
           </a:p>
         </p:txBody>
@@ -6345,6 +6659,54 @@
             <a:spAutoFit/>
           </a:bodyPr>
           <a:lstStyle/>
+          <a:p/>
+        </p:txBody>
+      </p:sp>
+      <p:pic>
+        <p:nvPicPr>
+          <p:cNvPr id="4" name="Picture 3" descr="S1-12.png"/>
+          <p:cNvPicPr>
+            <a:picLocks noChangeAspect="1"/>
+          </p:cNvPicPr>
+          <p:nvPr/>
+        </p:nvPicPr>
+        <p:blipFill>
+          <a:blip r:embed="rId2"/>
+          <a:stretch>
+            <a:fillRect/>
+          </a:stretch>
+        </p:blipFill>
+        <p:spPr>
+          <a:xfrm>
+            <a:off x="2590647" y="2468880"/>
+            <a:ext cx="7010400" cy="1828800"/>
+          </a:xfrm>
+          <a:prstGeom prst="rect">
+            <a:avLst/>
+          </a:prstGeom>
+        </p:spPr>
+      </p:pic>
+      <p:sp>
+        <p:nvSpPr>
+          <p:cNvPr id="5" name="TextBox 4"/>
+          <p:cNvSpPr txBox="1"/>
+          <p:nvPr/>
+        </p:nvSpPr>
+        <p:spPr>
+          <a:xfrm>
+            <a:off x="548640" y="5394960"/>
+            <a:ext cx="11094415" cy="365760"/>
+          </a:xfrm>
+          <a:prstGeom prst="rect">
+            <a:avLst/>
+          </a:prstGeom>
+          <a:noFill/>
+        </p:spPr>
+        <p:txBody>
+          <a:bodyPr wrap="square">
+            <a:spAutoFit/>
+          </a:bodyPr>
+          <a:lstStyle/>
           <a:p>
             <a:r>
               <a:rPr sz="1400" b="0" i="1">
@@ -6353,40 +6715,42 @@
                 </a:solidFill>
                 <a:latin typeface="Calibri"/>
               </a:rPr>
-              <a:t>[DIAGRAM SOURCE — draw by hand, not rendered by this script]  Il terminale come ciclo interattivo</a:t>
-            </a:r>
-          </a:p>
-          <a:p>
-            <a:r>
-              <a:rPr sz="1400" b="0" i="0">
-                <a:solidFill>
-                  <a:srgbClr val="1A1A1A"/>
-                </a:solidFill>
-                <a:latin typeface="Consolas"/>
-              </a:rPr>
-              <a:t>flowchart LR</a:t>
-            </a:r>
-          </a:p>
-          <a:p>
-            <a:r>
-              <a:rPr sz="1400" b="0" i="0">
-                <a:solidFill>
-                  <a:srgbClr val="1A1A1A"/>
-                </a:solidFill>
-                <a:latin typeface="Consolas"/>
-              </a:rPr>
-              <a:t>  Terminale -- stdin --&gt; Processo</a:t>
-            </a:r>
-          </a:p>
-          <a:p>
-            <a:r>
-              <a:rPr sz="1400" b="0" i="0">
-                <a:solidFill>
-                  <a:srgbClr val="1A1A1A"/>
-                </a:solidFill>
-                <a:latin typeface="Consolas"/>
-              </a:rPr>
-              <a:t>  Processo -- stdout --&gt; Terminale</a:t>
+              <a:t>Il terminale come ciclo interattivo</a:t>
+            </a:r>
+          </a:p>
+        </p:txBody>
+      </p:sp>
+      <p:sp>
+        <p:nvSpPr>
+          <p:cNvPr id="6" name="TextBox 5"/>
+          <p:cNvSpPr txBox="1"/>
+          <p:nvPr/>
+        </p:nvSpPr>
+        <p:spPr>
+          <a:xfrm>
+            <a:off x="10180015" y="137160"/>
+            <a:ext cx="1828800" cy="365760"/>
+          </a:xfrm>
+          <a:prstGeom prst="rect">
+            <a:avLst/>
+          </a:prstGeom>
+          <a:noFill/>
+        </p:spPr>
+        <p:txBody>
+          <a:bodyPr wrap="square">
+            <a:spAutoFit/>
+          </a:bodyPr>
+          <a:lstStyle/>
+          <a:p>
+            <a:pPr algn="r"/>
+            <a:r>
+              <a:rPr sz="1400" b="1" i="0">
+                <a:solidFill>
+                  <a:srgbClr val="C01C1C"/>
+                </a:solidFill>
+                <a:latin typeface="Calibri"/>
+              </a:rPr>
+              <a:t>[DRAFT]</a:t>
             </a:r>
           </a:p>
         </p:txBody>
@@ -6444,6 +6808,41 @@
           </a:p>
         </p:txBody>
       </p:sp>
+      <p:sp>
+        <p:nvSpPr>
+          <p:cNvPr id="3" name="TextBox 2"/>
+          <p:cNvSpPr txBox="1"/>
+          <p:nvPr/>
+        </p:nvSpPr>
+        <p:spPr>
+          <a:xfrm>
+            <a:off x="10180015" y="137160"/>
+            <a:ext cx="1828800" cy="365760"/>
+          </a:xfrm>
+          <a:prstGeom prst="rect">
+            <a:avLst/>
+          </a:prstGeom>
+          <a:noFill/>
+        </p:spPr>
+        <p:txBody>
+          <a:bodyPr wrap="square">
+            <a:spAutoFit/>
+          </a:bodyPr>
+          <a:lstStyle/>
+          <a:p>
+            <a:pPr algn="r"/>
+            <a:r>
+              <a:rPr sz="1400" b="1" i="0">
+                <a:solidFill>
+                  <a:srgbClr val="C01C1C"/>
+                </a:solidFill>
+                <a:latin typeface="Calibri"/>
+              </a:rPr>
+              <a:t>[DRAFT]</a:t>
+            </a:r>
+          </a:p>
+        </p:txBody>
+      </p:sp>
     </p:spTree>
   </p:cSld>
   <p:clrMapOvr>
@@ -6517,6 +6916,54 @@
             <a:spAutoFit/>
           </a:bodyPr>
           <a:lstStyle/>
+          <a:p/>
+        </p:txBody>
+      </p:sp>
+      <p:pic>
+        <p:nvPicPr>
+          <p:cNvPr id="4" name="Picture 3" descr="S1-13.png"/>
+          <p:cNvPicPr>
+            <a:picLocks noChangeAspect="1"/>
+          </p:cNvPicPr>
+          <p:nvPr/>
+        </p:nvPicPr>
+        <p:blipFill>
+          <a:blip r:embed="rId2"/>
+          <a:stretch>
+            <a:fillRect/>
+          </a:stretch>
+        </p:blipFill>
+        <p:spPr>
+          <a:xfrm>
+            <a:off x="2425547" y="2760980"/>
+            <a:ext cx="7340600" cy="1244600"/>
+          </a:xfrm>
+          <a:prstGeom prst="rect">
+            <a:avLst/>
+          </a:prstGeom>
+        </p:spPr>
+      </p:pic>
+      <p:sp>
+        <p:nvSpPr>
+          <p:cNvPr id="5" name="TextBox 4"/>
+          <p:cNvSpPr txBox="1"/>
+          <p:nvPr/>
+        </p:nvSpPr>
+        <p:spPr>
+          <a:xfrm>
+            <a:off x="548640" y="5394960"/>
+            <a:ext cx="11094415" cy="365760"/>
+          </a:xfrm>
+          <a:prstGeom prst="rect">
+            <a:avLst/>
+          </a:prstGeom>
+          <a:noFill/>
+        </p:spPr>
+        <p:txBody>
+          <a:bodyPr wrap="square">
+            <a:spAutoFit/>
+          </a:bodyPr>
+          <a:lstStyle/>
           <a:p>
             <a:r>
               <a:rPr sz="1400" b="0" i="1">
@@ -6525,29 +6972,42 @@
                 </a:solidFill>
                 <a:latin typeface="Calibri"/>
               </a:rPr>
-              <a:t>[DIAGRAM SOURCE — draw by hand, not rendered by this script]  Composizione di due comandi con una pipe</a:t>
-            </a:r>
-          </a:p>
-          <a:p>
-            <a:r>
-              <a:rPr sz="1400" b="0" i="0">
-                <a:solidFill>
-                  <a:srgbClr val="1A1A1A"/>
-                </a:solidFill>
-                <a:latin typeface="Consolas"/>
-              </a:rPr>
-              <a:t>flowchart LR</a:t>
-            </a:r>
-          </a:p>
-          <a:p>
-            <a:r>
-              <a:rPr sz="1400" b="0" i="0">
-                <a:solidFill>
-                  <a:srgbClr val="1A1A1A"/>
-                </a:solidFill>
-                <a:latin typeface="Consolas"/>
-              </a:rPr>
-              <a:t>  A[Processo A] -- pipe --&gt; B[Processo B]</a:t>
+              <a:t>Composizione di due comandi con una pipe</a:t>
+            </a:r>
+          </a:p>
+        </p:txBody>
+      </p:sp>
+      <p:sp>
+        <p:nvSpPr>
+          <p:cNvPr id="6" name="TextBox 5"/>
+          <p:cNvSpPr txBox="1"/>
+          <p:nvPr/>
+        </p:nvSpPr>
+        <p:spPr>
+          <a:xfrm>
+            <a:off x="10180015" y="137160"/>
+            <a:ext cx="1828800" cy="365760"/>
+          </a:xfrm>
+          <a:prstGeom prst="rect">
+            <a:avLst/>
+          </a:prstGeom>
+          <a:noFill/>
+        </p:spPr>
+        <p:txBody>
+          <a:bodyPr wrap="square">
+            <a:spAutoFit/>
+          </a:bodyPr>
+          <a:lstStyle/>
+          <a:p>
+            <a:pPr algn="r"/>
+            <a:r>
+              <a:rPr sz="1400" b="1" i="0">
+                <a:solidFill>
+                  <a:srgbClr val="C01C1C"/>
+                </a:solidFill>
+                <a:latin typeface="Calibri"/>
+              </a:rPr>
+              <a:t>[DRAFT]</a:t>
             </a:r>
           </a:p>
         </p:txBody>
@@ -6625,6 +7085,54 @@
             <a:spAutoFit/>
           </a:bodyPr>
           <a:lstStyle/>
+          <a:p/>
+        </p:txBody>
+      </p:sp>
+      <p:pic>
+        <p:nvPicPr>
+          <p:cNvPr id="4" name="Picture 3" descr="S1-14.png"/>
+          <p:cNvPicPr>
+            <a:picLocks noChangeAspect="1"/>
+          </p:cNvPicPr>
+          <p:nvPr/>
+        </p:nvPicPr>
+        <p:blipFill>
+          <a:blip r:embed="rId2"/>
+          <a:stretch>
+            <a:fillRect/>
+          </a:stretch>
+        </p:blipFill>
+        <p:spPr>
+          <a:xfrm>
+            <a:off x="548640" y="2966389"/>
+            <a:ext cx="11094415" cy="833782"/>
+          </a:xfrm>
+          <a:prstGeom prst="rect">
+            <a:avLst/>
+          </a:prstGeom>
+        </p:spPr>
+      </p:pic>
+      <p:sp>
+        <p:nvSpPr>
+          <p:cNvPr id="5" name="TextBox 4"/>
+          <p:cNvSpPr txBox="1"/>
+          <p:nvPr/>
+        </p:nvSpPr>
+        <p:spPr>
+          <a:xfrm>
+            <a:off x="548640" y="5394960"/>
+            <a:ext cx="11094415" cy="365760"/>
+          </a:xfrm>
+          <a:prstGeom prst="rect">
+            <a:avLst/>
+          </a:prstGeom>
+          <a:noFill/>
+        </p:spPr>
+        <p:txBody>
+          <a:bodyPr wrap="square">
+            <a:spAutoFit/>
+          </a:bodyPr>
+          <a:lstStyle/>
           <a:p>
             <a:r>
               <a:rPr sz="1400" b="0" i="1">
@@ -6633,40 +7141,42 @@
                 </a:solidFill>
                 <a:latin typeface="Calibri"/>
               </a:rPr>
-              <a:t>[DIAGRAM SOURCE — draw by hand, not rendered by this script]  Un segnale inviato a un processo</a:t>
-            </a:r>
-          </a:p>
-          <a:p>
-            <a:r>
-              <a:rPr sz="1400" b="0" i="0">
-                <a:solidFill>
-                  <a:srgbClr val="1A1A1A"/>
-                </a:solidFill>
-                <a:latin typeface="Consolas"/>
-              </a:rPr>
-              <a:t>flowchart LR</a:t>
-            </a:r>
-          </a:p>
-          <a:p>
-            <a:r>
-              <a:rPr sz="1400" b="0" i="0">
-                <a:solidFill>
-                  <a:srgbClr val="1A1A1A"/>
-                </a:solidFill>
-                <a:latin typeface="Consolas"/>
-              </a:rPr>
-              <a:t>  SO[Sistema operativo] -- segnale --&gt; P[Processo in esecuzione]</a:t>
-            </a:r>
-          </a:p>
-          <a:p>
-            <a:r>
-              <a:rPr sz="1400" b="0" i="0">
-                <a:solidFill>
-                  <a:srgbClr val="1A1A1A"/>
-                </a:solidFill>
-                <a:latin typeface="Consolas"/>
-              </a:rPr>
-              <a:t>  P --&gt; T[Processo terminato]</a:t>
+              <a:t>Un segnale inviato a un processo</a:t>
+            </a:r>
+          </a:p>
+        </p:txBody>
+      </p:sp>
+      <p:sp>
+        <p:nvSpPr>
+          <p:cNvPr id="6" name="TextBox 5"/>
+          <p:cNvSpPr txBox="1"/>
+          <p:nvPr/>
+        </p:nvSpPr>
+        <p:spPr>
+          <a:xfrm>
+            <a:off x="10180015" y="137160"/>
+            <a:ext cx="1828800" cy="365760"/>
+          </a:xfrm>
+          <a:prstGeom prst="rect">
+            <a:avLst/>
+          </a:prstGeom>
+          <a:noFill/>
+        </p:spPr>
+        <p:txBody>
+          <a:bodyPr wrap="square">
+            <a:spAutoFit/>
+          </a:bodyPr>
+          <a:lstStyle/>
+          <a:p>
+            <a:pPr algn="r"/>
+            <a:r>
+              <a:rPr sz="1400" b="1" i="0">
+                <a:solidFill>
+                  <a:srgbClr val="C01C1C"/>
+                </a:solidFill>
+                <a:latin typeface="Calibri"/>
+              </a:rPr>
+              <a:t>[DRAFT]</a:t>
             </a:r>
           </a:p>
         </p:txBody>
@@ -6758,6 +7268,41 @@
           </a:p>
         </p:txBody>
       </p:sp>
+      <p:sp>
+        <p:nvSpPr>
+          <p:cNvPr id="4" name="TextBox 3"/>
+          <p:cNvSpPr txBox="1"/>
+          <p:nvPr/>
+        </p:nvSpPr>
+        <p:spPr>
+          <a:xfrm>
+            <a:off x="10180015" y="137160"/>
+            <a:ext cx="1828800" cy="365760"/>
+          </a:xfrm>
+          <a:prstGeom prst="rect">
+            <a:avLst/>
+          </a:prstGeom>
+          <a:noFill/>
+        </p:spPr>
+        <p:txBody>
+          <a:bodyPr wrap="square">
+            <a:spAutoFit/>
+          </a:bodyPr>
+          <a:lstStyle/>
+          <a:p>
+            <a:pPr algn="r"/>
+            <a:r>
+              <a:rPr sz="1400" b="1" i="0">
+                <a:solidFill>
+                  <a:srgbClr val="C01C1C"/>
+                </a:solidFill>
+                <a:latin typeface="Calibri"/>
+              </a:rPr>
+              <a:t>[DRAFT]</a:t>
+            </a:r>
+          </a:p>
+        </p:txBody>
+      </p:sp>
     </p:spTree>
   </p:cSld>
   <p:clrMapOvr>
@@ -6831,6 +7376,54 @@
             <a:spAutoFit/>
           </a:bodyPr>
           <a:lstStyle/>
+          <a:p/>
+        </p:txBody>
+      </p:sp>
+      <p:pic>
+        <p:nvPicPr>
+          <p:cNvPr id="4" name="Picture 3" descr="S1-02.png"/>
+          <p:cNvPicPr>
+            <a:picLocks noChangeAspect="1"/>
+          </p:cNvPicPr>
+          <p:nvPr/>
+        </p:nvPicPr>
+        <p:blipFill>
+          <a:blip r:embed="rId2"/>
+          <a:stretch>
+            <a:fillRect/>
+          </a:stretch>
+        </p:blipFill>
+        <p:spPr>
+          <a:xfrm>
+            <a:off x="3380717" y="1463040"/>
+            <a:ext cx="5430260" cy="3840480"/>
+          </a:xfrm>
+          <a:prstGeom prst="rect">
+            <a:avLst/>
+          </a:prstGeom>
+        </p:spPr>
+      </p:pic>
+      <p:sp>
+        <p:nvSpPr>
+          <p:cNvPr id="5" name="TextBox 4"/>
+          <p:cNvSpPr txBox="1"/>
+          <p:nvPr/>
+        </p:nvSpPr>
+        <p:spPr>
+          <a:xfrm>
+            <a:off x="548640" y="5394960"/>
+            <a:ext cx="11094415" cy="365760"/>
+          </a:xfrm>
+          <a:prstGeom prst="rect">
+            <a:avLst/>
+          </a:prstGeom>
+          <a:noFill/>
+        </p:spPr>
+        <p:txBody>
+          <a:bodyPr wrap="square">
+            <a:spAutoFit/>
+          </a:bodyPr>
+          <a:lstStyle/>
           <a:p>
             <a:r>
               <a:rPr sz="1400" b="0" i="1">
@@ -6839,51 +7432,42 @@
                 </a:solidFill>
                 <a:latin typeface="Calibri"/>
               </a:rPr>
-              <a:t>[DIAGRAM SOURCE — draw by hand, not rendered by this script]  Stesso pacchetto, macchine diverse</a:t>
-            </a:r>
-          </a:p>
-          <a:p>
-            <a:r>
-              <a:rPr sz="1400" b="0" i="0">
-                <a:solidFill>
-                  <a:srgbClr val="1A1A1A"/>
-                </a:solidFill>
-                <a:latin typeface="Consolas"/>
-              </a:rPr>
-              <a:t>flowchart LR</a:t>
-            </a:r>
-          </a:p>
-          <a:p>
-            <a:r>
-              <a:rPr sz="1400" b="0" i="0">
-                <a:solidFill>
-                  <a:srgbClr val="1A1A1A"/>
-                </a:solidFill>
-                <a:latin typeface="Consolas"/>
-              </a:rPr>
-              <a:t>  I[Immagine Docker] --&gt; M1[Macchina 1]</a:t>
-            </a:r>
-          </a:p>
-          <a:p>
-            <a:r>
-              <a:rPr sz="1400" b="0" i="0">
-                <a:solidFill>
-                  <a:srgbClr val="1A1A1A"/>
-                </a:solidFill>
-                <a:latin typeface="Consolas"/>
-              </a:rPr>
-              <a:t>  I --&gt; M2[Macchina 2]</a:t>
-            </a:r>
-          </a:p>
-          <a:p>
-            <a:r>
-              <a:rPr sz="1400" b="0" i="0">
-                <a:solidFill>
-                  <a:srgbClr val="1A1A1A"/>
-                </a:solidFill>
-                <a:latin typeface="Consolas"/>
-              </a:rPr>
-              <a:t>  I --&gt; M3[Macchina 3]</a:t>
+              <a:t>Stesso pacchetto, macchine diverse</a:t>
+            </a:r>
+          </a:p>
+        </p:txBody>
+      </p:sp>
+      <p:sp>
+        <p:nvSpPr>
+          <p:cNvPr id="6" name="TextBox 5"/>
+          <p:cNvSpPr txBox="1"/>
+          <p:nvPr/>
+        </p:nvSpPr>
+        <p:spPr>
+          <a:xfrm>
+            <a:off x="10180015" y="137160"/>
+            <a:ext cx="1828800" cy="365760"/>
+          </a:xfrm>
+          <a:prstGeom prst="rect">
+            <a:avLst/>
+          </a:prstGeom>
+          <a:noFill/>
+        </p:spPr>
+        <p:txBody>
+          <a:bodyPr wrap="square">
+            <a:spAutoFit/>
+          </a:bodyPr>
+          <a:lstStyle/>
+          <a:p>
+            <a:pPr algn="r"/>
+            <a:r>
+              <a:rPr sz="1400" b="1" i="0">
+                <a:solidFill>
+                  <a:srgbClr val="C01C1C"/>
+                </a:solidFill>
+                <a:latin typeface="Calibri"/>
+              </a:rPr>
+              <a:t>[DRAFT]</a:t>
             </a:r>
           </a:p>
         </p:txBody>
@@ -6941,6 +7525,41 @@
           </a:p>
         </p:txBody>
       </p:sp>
+      <p:sp>
+        <p:nvSpPr>
+          <p:cNvPr id="3" name="TextBox 2"/>
+          <p:cNvSpPr txBox="1"/>
+          <p:nvPr/>
+        </p:nvSpPr>
+        <p:spPr>
+          <a:xfrm>
+            <a:off x="10180015" y="137160"/>
+            <a:ext cx="1828800" cy="365760"/>
+          </a:xfrm>
+          <a:prstGeom prst="rect">
+            <a:avLst/>
+          </a:prstGeom>
+          <a:noFill/>
+        </p:spPr>
+        <p:txBody>
+          <a:bodyPr wrap="square">
+            <a:spAutoFit/>
+          </a:bodyPr>
+          <a:lstStyle/>
+          <a:p>
+            <a:pPr algn="r"/>
+            <a:r>
+              <a:rPr sz="1400" b="1" i="0">
+                <a:solidFill>
+                  <a:srgbClr val="C01C1C"/>
+                </a:solidFill>
+                <a:latin typeface="Calibri"/>
+              </a:rPr>
+              <a:t>[DRAFT]</a:t>
+            </a:r>
+          </a:p>
+        </p:txBody>
+      </p:sp>
     </p:spTree>
   </p:cSld>
   <p:clrMapOvr>
@@ -7014,6 +7633,54 @@
             <a:spAutoFit/>
           </a:bodyPr>
           <a:lstStyle/>
+          <a:p/>
+        </p:txBody>
+      </p:sp>
+      <p:pic>
+        <p:nvPicPr>
+          <p:cNvPr id="4" name="Picture 3" descr="S1-03.png"/>
+          <p:cNvPicPr>
+            <a:picLocks noChangeAspect="1"/>
+          </p:cNvPicPr>
+          <p:nvPr/>
+        </p:nvPicPr>
+        <p:blipFill>
+          <a:blip r:embed="rId2"/>
+          <a:stretch>
+            <a:fillRect/>
+          </a:stretch>
+        </p:blipFill>
+        <p:spPr>
+          <a:xfrm>
+            <a:off x="4175607" y="1463040"/>
+            <a:ext cx="3840480" cy="3840480"/>
+          </a:xfrm>
+          <a:prstGeom prst="rect">
+            <a:avLst/>
+          </a:prstGeom>
+        </p:spPr>
+      </p:pic>
+      <p:sp>
+        <p:nvSpPr>
+          <p:cNvPr id="5" name="TextBox 4"/>
+          <p:cNvSpPr txBox="1"/>
+          <p:nvPr/>
+        </p:nvSpPr>
+        <p:spPr>
+          <a:xfrm>
+            <a:off x="548640" y="5394960"/>
+            <a:ext cx="11094415" cy="365760"/>
+          </a:xfrm>
+          <a:prstGeom prst="rect">
+            <a:avLst/>
+          </a:prstGeom>
+          <a:noFill/>
+        </p:spPr>
+        <p:txBody>
+          <a:bodyPr wrap="square">
+            <a:spAutoFit/>
+          </a:bodyPr>
+          <a:lstStyle/>
           <a:p>
             <a:r>
               <a:rPr sz="1400" b="0" i="1">
@@ -7022,73 +7689,42 @@
                 </a:solidFill>
                 <a:latin typeface="Calibri"/>
               </a:rPr>
-              <a:t>[DIAGRAM SOURCE — draw by hand, not rendered by this script]  Programmi sulla stessa macchina, isolati tra loro</a:t>
-            </a:r>
-          </a:p>
-          <a:p>
-            <a:r>
-              <a:rPr sz="1400" b="0" i="0">
-                <a:solidFill>
-                  <a:srgbClr val="1A1A1A"/>
-                </a:solidFill>
-                <a:latin typeface="Consolas"/>
-              </a:rPr>
-              <a:t>flowchart LR</a:t>
-            </a:r>
-          </a:p>
-          <a:p>
-            <a:r>
-              <a:rPr sz="1400" b="0" i="0">
-                <a:solidFill>
-                  <a:srgbClr val="1A1A1A"/>
-                </a:solidFill>
-                <a:latin typeface="Consolas"/>
-              </a:rPr>
-              <a:t>  subgraph PC[Computer]</a:t>
-            </a:r>
-          </a:p>
-          <a:p>
-            <a:r>
-              <a:rPr sz="1400" b="0" i="0">
-                <a:solidFill>
-                  <a:srgbClr val="1A1A1A"/>
-                </a:solidFill>
-                <a:latin typeface="Consolas"/>
-              </a:rPr>
-              <a:t>    P1[Programma A]</a:t>
-            </a:r>
-          </a:p>
-          <a:p>
-            <a:r>
-              <a:rPr sz="1400" b="0" i="0">
-                <a:solidFill>
-                  <a:srgbClr val="1A1A1A"/>
-                </a:solidFill>
-                <a:latin typeface="Consolas"/>
-              </a:rPr>
-              <a:t>    P2[Programma B]</a:t>
-            </a:r>
-          </a:p>
-          <a:p>
-            <a:r>
-              <a:rPr sz="1400" b="0" i="0">
-                <a:solidFill>
-                  <a:srgbClr val="1A1A1A"/>
-                </a:solidFill>
-                <a:latin typeface="Consolas"/>
-              </a:rPr>
-              <a:t>  end</a:t>
-            </a:r>
-          </a:p>
-          <a:p>
-            <a:r>
-              <a:rPr sz="1400" b="0" i="0">
-                <a:solidFill>
-                  <a:srgbClr val="1A1A1A"/>
-                </a:solidFill>
-                <a:latin typeface="Consolas"/>
-              </a:rPr>
-              <a:t>  P1 -.non interferisce.-&gt; P2</a:t>
+              <a:t>Programmi sulla stessa macchina, isolati tra loro</a:t>
+            </a:r>
+          </a:p>
+        </p:txBody>
+      </p:sp>
+      <p:sp>
+        <p:nvSpPr>
+          <p:cNvPr id="6" name="TextBox 5"/>
+          <p:cNvSpPr txBox="1"/>
+          <p:nvPr/>
+        </p:nvSpPr>
+        <p:spPr>
+          <a:xfrm>
+            <a:off x="10180015" y="137160"/>
+            <a:ext cx="1828800" cy="365760"/>
+          </a:xfrm>
+          <a:prstGeom prst="rect">
+            <a:avLst/>
+          </a:prstGeom>
+          <a:noFill/>
+        </p:spPr>
+        <p:txBody>
+          <a:bodyPr wrap="square">
+            <a:spAutoFit/>
+          </a:bodyPr>
+          <a:lstStyle/>
+          <a:p>
+            <a:pPr algn="r"/>
+            <a:r>
+              <a:rPr sz="1400" b="1" i="0">
+                <a:solidFill>
+                  <a:srgbClr val="C01C1C"/>
+                </a:solidFill>
+                <a:latin typeface="Calibri"/>
+              </a:rPr>
+              <a:t>[DRAFT]</a:t>
             </a:r>
           </a:p>
         </p:txBody>
@@ -7146,6 +7782,41 @@
           </a:p>
         </p:txBody>
       </p:sp>
+      <p:sp>
+        <p:nvSpPr>
+          <p:cNvPr id="3" name="TextBox 2"/>
+          <p:cNvSpPr txBox="1"/>
+          <p:nvPr/>
+        </p:nvSpPr>
+        <p:spPr>
+          <a:xfrm>
+            <a:off x="10180015" y="137160"/>
+            <a:ext cx="1828800" cy="365760"/>
+          </a:xfrm>
+          <a:prstGeom prst="rect">
+            <a:avLst/>
+          </a:prstGeom>
+          <a:noFill/>
+        </p:spPr>
+        <p:txBody>
+          <a:bodyPr wrap="square">
+            <a:spAutoFit/>
+          </a:bodyPr>
+          <a:lstStyle/>
+          <a:p>
+            <a:pPr algn="r"/>
+            <a:r>
+              <a:rPr sz="1400" b="1" i="0">
+                <a:solidFill>
+                  <a:srgbClr val="C01C1C"/>
+                </a:solidFill>
+                <a:latin typeface="Calibri"/>
+              </a:rPr>
+              <a:t>[DRAFT]</a:t>
+            </a:r>
+          </a:p>
+        </p:txBody>
+      </p:sp>
     </p:spTree>
   </p:cSld>
   <p:clrMapOvr>
@@ -7219,6 +7890,54 @@
             <a:spAutoFit/>
           </a:bodyPr>
           <a:lstStyle/>
+          <a:p/>
+        </p:txBody>
+      </p:sp>
+      <p:pic>
+        <p:nvPicPr>
+          <p:cNvPr id="4" name="Picture 3" descr="S1-04.png"/>
+          <p:cNvPicPr>
+            <a:picLocks noChangeAspect="1"/>
+          </p:cNvPicPr>
+          <p:nvPr/>
+        </p:nvPicPr>
+        <p:blipFill>
+          <a:blip r:embed="rId2"/>
+          <a:stretch>
+            <a:fillRect/>
+          </a:stretch>
+        </p:blipFill>
+        <p:spPr>
+          <a:xfrm>
+            <a:off x="548640" y="2086630"/>
+            <a:ext cx="11094415" cy="2593300"/>
+          </a:xfrm>
+          <a:prstGeom prst="rect">
+            <a:avLst/>
+          </a:prstGeom>
+        </p:spPr>
+      </p:pic>
+      <p:sp>
+        <p:nvSpPr>
+          <p:cNvPr id="5" name="TextBox 4"/>
+          <p:cNvSpPr txBox="1"/>
+          <p:nvPr/>
+        </p:nvSpPr>
+        <p:spPr>
+          <a:xfrm>
+            <a:off x="548640" y="5394960"/>
+            <a:ext cx="11094415" cy="365760"/>
+          </a:xfrm>
+          <a:prstGeom prst="rect">
+            <a:avLst/>
+          </a:prstGeom>
+          <a:noFill/>
+        </p:spPr>
+        <p:txBody>
+          <a:bodyPr wrap="square">
+            <a:spAutoFit/>
+          </a:bodyPr>
+          <a:lstStyle/>
           <a:p>
             <a:r>
               <a:rPr sz="1400" b="0" i="1">
@@ -7227,106 +7946,42 @@
                 </a:solidFill>
                 <a:latin typeface="Calibri"/>
               </a:rPr>
-              <a:t>[DIAGRAM SOURCE — draw by hand, not rendered by this script]  Un container sull'host</a:t>
-            </a:r>
-          </a:p>
-          <a:p>
-            <a:r>
-              <a:rPr sz="1400" b="0" i="0">
-                <a:solidFill>
-                  <a:srgbClr val="1A1A1A"/>
-                </a:solidFill>
-                <a:latin typeface="Consolas"/>
-              </a:rPr>
-              <a:t>flowchart TB</a:t>
-            </a:r>
-          </a:p>
-          <a:p>
-            <a:r>
-              <a:rPr sz="1400" b="0" i="0">
-                <a:solidFill>
-                  <a:srgbClr val="1A1A1A"/>
-                </a:solidFill>
-                <a:latin typeface="Consolas"/>
-              </a:rPr>
-              <a:t>  subgraph Host[Computer host]</a:t>
-            </a:r>
-          </a:p>
-          <a:p>
-            <a:r>
-              <a:rPr sz="1400" b="0" i="0">
-                <a:solidFill>
-                  <a:srgbClr val="1A1A1A"/>
-                </a:solidFill>
-                <a:latin typeface="Consolas"/>
-              </a:rPr>
-              <a:t>    K[Kernel del sistema operativo]</a:t>
-            </a:r>
-          </a:p>
-          <a:p>
-            <a:r>
-              <a:rPr sz="1400" b="0" i="0">
-                <a:solidFill>
-                  <a:srgbClr val="1A1A1A"/>
-                </a:solidFill>
-                <a:latin typeface="Consolas"/>
-              </a:rPr>
-              <a:t>    subgraph C[Container]</a:t>
-            </a:r>
-          </a:p>
-          <a:p>
-            <a:r>
-              <a:rPr sz="1400" b="0" i="0">
-                <a:solidFill>
-                  <a:srgbClr val="1A1A1A"/>
-                </a:solidFill>
-                <a:latin typeface="Consolas"/>
-              </a:rPr>
-              <a:t>      Pr[Processo]</a:t>
-            </a:r>
-          </a:p>
-          <a:p>
-            <a:r>
-              <a:rPr sz="1400" b="0" i="0">
-                <a:solidFill>
-                  <a:srgbClr val="1A1A1A"/>
-                </a:solidFill>
-                <a:latin typeface="Consolas"/>
-              </a:rPr>
-              <a:t>      FS[Filesystem del container]</a:t>
-            </a:r>
-          </a:p>
-          <a:p>
-            <a:r>
-              <a:rPr sz="1400" b="0" i="0">
-                <a:solidFill>
-                  <a:srgbClr val="1A1A1A"/>
-                </a:solidFill>
-                <a:latin typeface="Consolas"/>
-              </a:rPr>
-              <a:t>    end</a:t>
-            </a:r>
-          </a:p>
-          <a:p>
-            <a:r>
-              <a:rPr sz="1400" b="0" i="0">
-                <a:solidFill>
-                  <a:srgbClr val="1A1A1A"/>
-                </a:solidFill>
-                <a:latin typeface="Consolas"/>
-              </a:rPr>
-              <a:t>  end</a:t>
-            </a:r>
-          </a:p>
-          <a:p>
-            <a:r>
-              <a:rPr sz="1400" b="0" i="0">
-                <a:solidFill>
-                  <a:srgbClr val="1A1A1A"/>
-                </a:solidFill>
-                <a:latin typeface="Consolas"/>
-              </a:rPr>
-              <a:t>  K --&gt; C</a:t>
+              <a:t>Un container sull'host</a:t>
+            </a:r>
+          </a:p>
+        </p:txBody>
+      </p:sp>
+      <p:sp>
+        <p:nvSpPr>
+          <p:cNvPr id="6" name="TextBox 5"/>
+          <p:cNvSpPr txBox="1"/>
+          <p:nvPr/>
+        </p:nvSpPr>
+        <p:spPr>
+          <a:xfrm>
+            <a:off x="10180015" y="137160"/>
+            <a:ext cx="1828800" cy="365760"/>
+          </a:xfrm>
+          <a:prstGeom prst="rect">
+            <a:avLst/>
+          </a:prstGeom>
+          <a:noFill/>
+        </p:spPr>
+        <p:txBody>
+          <a:bodyPr wrap="square">
+            <a:spAutoFit/>
+          </a:bodyPr>
+          <a:lstStyle/>
+          <a:p>
+            <a:pPr algn="r"/>
+            <a:r>
+              <a:rPr sz="1400" b="1" i="0">
+                <a:solidFill>
+                  <a:srgbClr val="C01C1C"/>
+                </a:solidFill>
+                <a:latin typeface="Calibri"/>
+              </a:rPr>
+              <a:t>[DRAFT]</a:t>
             </a:r>
           </a:p>
         </p:txBody>
@@ -7404,6 +8059,54 @@
             <a:spAutoFit/>
           </a:bodyPr>
           <a:lstStyle/>
+          <a:p/>
+        </p:txBody>
+      </p:sp>
+      <p:pic>
+        <p:nvPicPr>
+          <p:cNvPr id="4" name="Picture 3" descr="S1-05.png"/>
+          <p:cNvPicPr>
+            <a:picLocks noChangeAspect="1"/>
+          </p:cNvPicPr>
+          <p:nvPr/>
+        </p:nvPicPr>
+        <p:blipFill>
+          <a:blip r:embed="rId2"/>
+          <a:stretch>
+            <a:fillRect/>
+          </a:stretch>
+        </p:blipFill>
+        <p:spPr>
+          <a:xfrm>
+            <a:off x="548640" y="2548369"/>
+            <a:ext cx="11094415" cy="1669822"/>
+          </a:xfrm>
+          <a:prstGeom prst="rect">
+            <a:avLst/>
+          </a:prstGeom>
+        </p:spPr>
+      </p:pic>
+      <p:sp>
+        <p:nvSpPr>
+          <p:cNvPr id="5" name="TextBox 4"/>
+          <p:cNvSpPr txBox="1"/>
+          <p:nvPr/>
+        </p:nvSpPr>
+        <p:spPr>
+          <a:xfrm>
+            <a:off x="548640" y="5394960"/>
+            <a:ext cx="11094415" cy="365760"/>
+          </a:xfrm>
+          <a:prstGeom prst="rect">
+            <a:avLst/>
+          </a:prstGeom>
+          <a:noFill/>
+        </p:spPr>
+        <p:txBody>
+          <a:bodyPr wrap="square">
+            <a:spAutoFit/>
+          </a:bodyPr>
+          <a:lstStyle/>
           <a:p>
             <a:r>
               <a:rPr sz="1400" b="0" i="1">
@@ -7412,84 +8115,42 @@
                 </a:solidFill>
                 <a:latin typeface="Calibri"/>
               </a:rPr>
-              <a:t>[DIAGRAM SOURCE — draw by hand, not rendered by this script]  Due modelli a confronto</a:t>
-            </a:r>
-          </a:p>
-          <a:p>
-            <a:r>
-              <a:rPr sz="1400" b="0" i="0">
-                <a:solidFill>
-                  <a:srgbClr val="1A1A1A"/>
-                </a:solidFill>
-                <a:latin typeface="Consolas"/>
-              </a:rPr>
-              <a:t>flowchart TB</a:t>
-            </a:r>
-          </a:p>
-          <a:p>
-            <a:r>
-              <a:rPr sz="1400" b="0" i="0">
-                <a:solidFill>
-                  <a:srgbClr val="1A1A1A"/>
-                </a:solidFill>
-                <a:latin typeface="Consolas"/>
-              </a:rPr>
-              <a:t>  subgraph VM[Macchina virtuale]</a:t>
-            </a:r>
-          </a:p>
-          <a:p>
-            <a:r>
-              <a:rPr sz="1400" b="0" i="0">
-                <a:solidFill>
-                  <a:srgbClr val="1A1A1A"/>
-                </a:solidFill>
-                <a:latin typeface="Consolas"/>
-              </a:rPr>
-              <a:t>    K1[Kernel proprio] --&gt; A1[Applicazione]</a:t>
-            </a:r>
-          </a:p>
-          <a:p>
-            <a:r>
-              <a:rPr sz="1400" b="0" i="0">
-                <a:solidFill>
-                  <a:srgbClr val="1A1A1A"/>
-                </a:solidFill>
-                <a:latin typeface="Consolas"/>
-              </a:rPr>
-              <a:t>  end</a:t>
-            </a:r>
-          </a:p>
-          <a:p>
-            <a:r>
-              <a:rPr sz="1400" b="0" i="0">
-                <a:solidFill>
-                  <a:srgbClr val="1A1A1A"/>
-                </a:solidFill>
-                <a:latin typeface="Consolas"/>
-              </a:rPr>
-              <a:t>  subgraph CT[Container]</a:t>
-            </a:r>
-          </a:p>
-          <a:p>
-            <a:r>
-              <a:rPr sz="1400" b="0" i="0">
-                <a:solidFill>
-                  <a:srgbClr val="1A1A1A"/>
-                </a:solidFill>
-                <a:latin typeface="Consolas"/>
-              </a:rPr>
-              <a:t>    K2[Kernel condiviso con l'host] --&gt; A2[Applicazione]</a:t>
-            </a:r>
-          </a:p>
-          <a:p>
-            <a:r>
-              <a:rPr sz="1400" b="0" i="0">
-                <a:solidFill>
-                  <a:srgbClr val="1A1A1A"/>
-                </a:solidFill>
-                <a:latin typeface="Consolas"/>
-              </a:rPr>
-              <a:t>  end</a:t>
+              <a:t>Due modelli a confronto</a:t>
+            </a:r>
+          </a:p>
+        </p:txBody>
+      </p:sp>
+      <p:sp>
+        <p:nvSpPr>
+          <p:cNvPr id="6" name="TextBox 5"/>
+          <p:cNvSpPr txBox="1"/>
+          <p:nvPr/>
+        </p:nvSpPr>
+        <p:spPr>
+          <a:xfrm>
+            <a:off x="10180015" y="137160"/>
+            <a:ext cx="1828800" cy="365760"/>
+          </a:xfrm>
+          <a:prstGeom prst="rect">
+            <a:avLst/>
+          </a:prstGeom>
+          <a:noFill/>
+        </p:spPr>
+        <p:txBody>
+          <a:bodyPr wrap="square">
+            <a:spAutoFit/>
+          </a:bodyPr>
+          <a:lstStyle/>
+          <a:p>
+            <a:pPr algn="r"/>
+            <a:r>
+              <a:rPr sz="1400" b="1" i="0">
+                <a:solidFill>
+                  <a:srgbClr val="C01C1C"/>
+                </a:solidFill>
+                <a:latin typeface="Calibri"/>
+              </a:rPr>
+              <a:t>[DRAFT]</a:t>
             </a:r>
           </a:p>
         </p:txBody>

</xml_diff>